<commit_message>
Move Kit 3 scripture cross clear of verse text
</commit_message>
<xml_diff>
--- a/Sermon-Kit-3-The-Weightless-King.pptx
+++ b/Sermon-Kit-3-The-Weightless-King.pptx
@@ -9397,8 +9397,8 @@
         </p:nvSpPr>
         <p:spPr>
           <a:xfrm>
-            <a:off x="9948672" y="1719072"/>
-            <a:ext cx="73152" cy="2093976"/>
+            <a:off x="10835640" y="2487168"/>
+            <a:ext cx="73152" cy="1024128"/>
           </a:xfrm>
           <a:prstGeom prst="rect">
             <a:avLst/>
@@ -9441,8 +9441,8 @@
         </p:nvSpPr>
         <p:spPr>
           <a:xfrm>
-            <a:off x="9427464" y="2286000"/>
-            <a:ext cx="1106424" cy="73152"/>
+            <a:off x="10378440" y="2898648"/>
+            <a:ext cx="987552" cy="73152"/>
           </a:xfrm>
           <a:prstGeom prst="rect">
             <a:avLst/>

</xml_diff>